<commit_message>
refactor: rename project to SentinelGrid across codebase and assets
</commit_message>
<xml_diff>
--- a/PITCH_DECK.pptx
+++ b/PITCH_DECK.pptx
@@ -3214,7 +3214,7 @@
               </a:defRPr>
             </a:pPr>
             <a:r>
-              <a:t>SentinelMind AI</a:t>
+              <a:t>SentinelGrid</a:t>
             </a:r>
           </a:p>
           <a:p>
@@ -3880,7 +3880,7 @@
               </a:defRPr>
             </a:pPr>
             <a:r>
-              <a:t>🛡️ The SentinelMind AI Solution</a:t>
+              <a:t>🛡️ The SentinelGrid Solution</a:t>
             </a:r>
           </a:p>
           <a:p>
@@ -6651,7 +6651,7 @@
               </a:defRPr>
             </a:pPr>
             <a:r>
-              <a:t>SENTINELMIND EDGE</a:t>
+              <a:t>SENTINELGRID EDGE</a:t>
             </a:r>
           </a:p>
         </p:txBody>

</xml_diff>